<commit_message>
added the ideas and added the target audiance
</commit_message>
<xml_diff>
--- a/three_ideas.pptx
+++ b/three_ideas.pptx
@@ -5,12 +5,15 @@
     <p:sldMasterId id="2147483648" r:id="rId1"/>
   </p:sldMasterIdLst>
   <p:notesMasterIdLst>
-    <p:notesMasterId r:id="rId5"/>
+    <p:notesMasterId r:id="rId8"/>
   </p:notesMasterIdLst>
   <p:sldIdLst>
     <p:sldId id="256" r:id="rId2"/>
     <p:sldId id="257" r:id="rId3"/>
     <p:sldId id="258" r:id="rId4"/>
+    <p:sldId id="259" r:id="rId5"/>
+    <p:sldId id="260" r:id="rId6"/>
+    <p:sldId id="261" r:id="rId7"/>
   </p:sldIdLst>
   <p:sldSz cx="12192000" cy="6858000"/>
   <p:notesSz cx="6858000" cy="12192000"/>
@@ -139,7 +142,7 @@
     </p:spTree>
     <p:extLst>
       <p:ext uri="{BB962C8B-B14F-4D97-AF65-F5344CB8AC3E}">
-        <p14:creationId xmlns:p14="http://schemas.microsoft.com/office/powerpoint/2010/main" val="1316917127"/>
+        <p14:creationId xmlns:p14="http://schemas.microsoft.com/office/powerpoint/2010/main" val="395699440"/>
       </p:ext>
     </p:extLst>
   </p:cSld>
@@ -491,6 +494,258 @@
 </p:notes>
 </file>
 
+<file path=ppt/notesSlides/notesSlide4.xml><?xml version="1.0" encoding="utf-8"?>
+<p:notes xmlns:a="http://schemas.openxmlformats.org/drawingml/2006/main" xmlns:r="http://schemas.openxmlformats.org/officeDocument/2006/relationships" xmlns:p="http://schemas.openxmlformats.org/presentationml/2006/main">
+  <p:cSld>
+    <p:spTree>
+      <p:nvGrpSpPr>
+        <p:cNvPr id="1" name=""/>
+        <p:cNvGrpSpPr/>
+        <p:nvPr/>
+      </p:nvGrpSpPr>
+      <p:grpSpPr>
+        <a:xfrm>
+          <a:off x="0" y="0"/>
+          <a:ext cx="0" cy="0"/>
+          <a:chOff x="0" y="0"/>
+          <a:chExt cx="0" cy="0"/>
+        </a:xfrm>
+      </p:grpSpPr>
+      <p:sp>
+        <p:nvSpPr>
+          <p:cNvPr id="2" name="Slide Image Placeholder 1"/>
+          <p:cNvSpPr>
+            <a:spLocks noGrp="1" noRot="1" noChangeAspect="1"/>
+          </p:cNvSpPr>
+          <p:nvPr>
+            <p:ph type="sldImg"/>
+          </p:nvPr>
+        </p:nvSpPr>
+        <p:spPr/>
+      </p:sp>
+      <p:sp>
+        <p:nvSpPr>
+          <p:cNvPr id="3" name="Notes Placeholder 2"/>
+          <p:cNvSpPr>
+            <a:spLocks noGrp="1"/>
+          </p:cNvSpPr>
+          <p:nvPr>
+            <p:ph type="body" idx="1"/>
+          </p:nvPr>
+        </p:nvSpPr>
+        <p:spPr/>
+        <p:txBody>
+          <a:bodyPr/>
+          <a:lstStyle/>
+          <a:p>
+            <a:endParaRPr lang="en-US" dirty="0"/>
+          </a:p>
+        </p:txBody>
+      </p:sp>
+      <p:sp>
+        <p:nvSpPr>
+          <p:cNvPr id="4" name="Slide Number Placeholder 3"/>
+          <p:cNvSpPr>
+            <a:spLocks noGrp="1"/>
+          </p:cNvSpPr>
+          <p:nvPr>
+            <p:ph type="sldNum" sz="quarter" idx="10"/>
+          </p:nvPr>
+        </p:nvSpPr>
+        <p:spPr/>
+        <p:txBody>
+          <a:bodyPr/>
+          <a:lstStyle/>
+          <a:p>
+            <a:fld id="{F7021451-1387-4CA6-816F-3879F97B5CBC}" type="slidenum">
+              <a:rPr lang="en-US"/>
+              <a:t>4</a:t>
+            </a:fld>
+            <a:endParaRPr lang="en-US"/>
+          </a:p>
+        </p:txBody>
+      </p:sp>
+    </p:spTree>
+    <p:extLst>
+      <p:ext uri="{BB962C8B-B14F-4D97-AF65-F5344CB8AC3E}">
+        <p14:creationId xmlns:p14="http://schemas.microsoft.com/office/powerpoint/2010/main" val="1024086991"/>
+      </p:ext>
+    </p:extLst>
+  </p:cSld>
+  <p:clrMapOvr>
+    <a:masterClrMapping/>
+  </p:clrMapOvr>
+</p:notes>
+</file>
+
+<file path=ppt/notesSlides/notesSlide5.xml><?xml version="1.0" encoding="utf-8"?>
+<p:notes xmlns:a="http://schemas.openxmlformats.org/drawingml/2006/main" xmlns:r="http://schemas.openxmlformats.org/officeDocument/2006/relationships" xmlns:p="http://schemas.openxmlformats.org/presentationml/2006/main">
+  <p:cSld>
+    <p:spTree>
+      <p:nvGrpSpPr>
+        <p:cNvPr id="1" name=""/>
+        <p:cNvGrpSpPr/>
+        <p:nvPr/>
+      </p:nvGrpSpPr>
+      <p:grpSpPr>
+        <a:xfrm>
+          <a:off x="0" y="0"/>
+          <a:ext cx="0" cy="0"/>
+          <a:chOff x="0" y="0"/>
+          <a:chExt cx="0" cy="0"/>
+        </a:xfrm>
+      </p:grpSpPr>
+      <p:sp>
+        <p:nvSpPr>
+          <p:cNvPr id="2" name="Slide Image Placeholder 1"/>
+          <p:cNvSpPr>
+            <a:spLocks noGrp="1" noRot="1" noChangeAspect="1"/>
+          </p:cNvSpPr>
+          <p:nvPr>
+            <p:ph type="sldImg"/>
+          </p:nvPr>
+        </p:nvSpPr>
+        <p:spPr/>
+      </p:sp>
+      <p:sp>
+        <p:nvSpPr>
+          <p:cNvPr id="3" name="Notes Placeholder 2"/>
+          <p:cNvSpPr>
+            <a:spLocks noGrp="1"/>
+          </p:cNvSpPr>
+          <p:nvPr>
+            <p:ph type="body" idx="1"/>
+          </p:nvPr>
+        </p:nvSpPr>
+        <p:spPr/>
+        <p:txBody>
+          <a:bodyPr/>
+          <a:lstStyle/>
+          <a:p>
+            <a:endParaRPr lang="en-US" dirty="0"/>
+          </a:p>
+        </p:txBody>
+      </p:sp>
+      <p:sp>
+        <p:nvSpPr>
+          <p:cNvPr id="4" name="Slide Number Placeholder 3"/>
+          <p:cNvSpPr>
+            <a:spLocks noGrp="1"/>
+          </p:cNvSpPr>
+          <p:nvPr>
+            <p:ph type="sldNum" sz="quarter" idx="10"/>
+          </p:nvPr>
+        </p:nvSpPr>
+        <p:spPr/>
+        <p:txBody>
+          <a:bodyPr/>
+          <a:lstStyle/>
+          <a:p>
+            <a:fld id="{F7021451-1387-4CA6-816F-3879F97B5CBC}" type="slidenum">
+              <a:rPr lang="en-US"/>
+              <a:t>5</a:t>
+            </a:fld>
+            <a:endParaRPr lang="en-US"/>
+          </a:p>
+        </p:txBody>
+      </p:sp>
+    </p:spTree>
+    <p:extLst>
+      <p:ext uri="{BB962C8B-B14F-4D97-AF65-F5344CB8AC3E}">
+        <p14:creationId xmlns:p14="http://schemas.microsoft.com/office/powerpoint/2010/main" val="1024086991"/>
+      </p:ext>
+    </p:extLst>
+  </p:cSld>
+  <p:clrMapOvr>
+    <a:masterClrMapping/>
+  </p:clrMapOvr>
+</p:notes>
+</file>
+
+<file path=ppt/notesSlides/notesSlide6.xml><?xml version="1.0" encoding="utf-8"?>
+<p:notes xmlns:a="http://schemas.openxmlformats.org/drawingml/2006/main" xmlns:r="http://schemas.openxmlformats.org/officeDocument/2006/relationships" xmlns:p="http://schemas.openxmlformats.org/presentationml/2006/main">
+  <p:cSld>
+    <p:spTree>
+      <p:nvGrpSpPr>
+        <p:cNvPr id="1" name=""/>
+        <p:cNvGrpSpPr/>
+        <p:nvPr/>
+      </p:nvGrpSpPr>
+      <p:grpSpPr>
+        <a:xfrm>
+          <a:off x="0" y="0"/>
+          <a:ext cx="0" cy="0"/>
+          <a:chOff x="0" y="0"/>
+          <a:chExt cx="0" cy="0"/>
+        </a:xfrm>
+      </p:grpSpPr>
+      <p:sp>
+        <p:nvSpPr>
+          <p:cNvPr id="2" name="Slide Image Placeholder 1"/>
+          <p:cNvSpPr>
+            <a:spLocks noGrp="1" noRot="1" noChangeAspect="1"/>
+          </p:cNvSpPr>
+          <p:nvPr>
+            <p:ph type="sldImg"/>
+          </p:nvPr>
+        </p:nvSpPr>
+        <p:spPr/>
+      </p:sp>
+      <p:sp>
+        <p:nvSpPr>
+          <p:cNvPr id="3" name="Notes Placeholder 2"/>
+          <p:cNvSpPr>
+            <a:spLocks noGrp="1"/>
+          </p:cNvSpPr>
+          <p:nvPr>
+            <p:ph type="body" idx="1"/>
+          </p:nvPr>
+        </p:nvSpPr>
+        <p:spPr/>
+        <p:txBody>
+          <a:bodyPr/>
+          <a:lstStyle/>
+          <a:p>
+            <a:endParaRPr lang="en-US" dirty="0"/>
+          </a:p>
+        </p:txBody>
+      </p:sp>
+      <p:sp>
+        <p:nvSpPr>
+          <p:cNvPr id="4" name="Slide Number Placeholder 3"/>
+          <p:cNvSpPr>
+            <a:spLocks noGrp="1"/>
+          </p:cNvSpPr>
+          <p:nvPr>
+            <p:ph type="sldNum" sz="quarter" idx="10"/>
+          </p:nvPr>
+        </p:nvSpPr>
+        <p:spPr/>
+        <p:txBody>
+          <a:bodyPr/>
+          <a:lstStyle/>
+          <a:p>
+            <a:fld id="{F7021451-1387-4CA6-816F-3879F97B5CBC}" type="slidenum">
+              <a:rPr lang="en-US"/>
+              <a:t>6</a:t>
+            </a:fld>
+            <a:endParaRPr lang="en-US"/>
+          </a:p>
+        </p:txBody>
+      </p:sp>
+    </p:spTree>
+    <p:extLst>
+      <p:ext uri="{BB962C8B-B14F-4D97-AF65-F5344CB8AC3E}">
+        <p14:creationId xmlns:p14="http://schemas.microsoft.com/office/powerpoint/2010/main" val="1024086991"/>
+      </p:ext>
+    </p:extLst>
+  </p:cSld>
+  <p:clrMapOvr>
+    <a:masterClrMapping/>
+  </p:clrMapOvr>
+</p:notes>
+</file>
+
 <file path=ppt/slideLayouts/slideLayout1.xml><?xml version="1.0" encoding="utf-8"?>
 <p:sldLayout xmlns:a="http://schemas.openxmlformats.org/drawingml/2006/main" xmlns:r="http://schemas.openxmlformats.org/officeDocument/2006/relationships" xmlns:p="http://schemas.openxmlformats.org/presentationml/2006/main" preserve="1">
   <p:cSld name="DEFAULT">
@@ -990,7 +1245,7 @@
         </p:nvSpPr>
         <p:spPr>
           <a:xfrm>
-            <a:off x="640080" y="2564934"/>
+            <a:off x="640080" y="2514600"/>
             <a:ext cx="10881360" cy="822960"/>
           </a:xfrm>
           <a:prstGeom prst="rect">
@@ -1129,6 +1384,14 @@
             <a:pPr marL="0" indent="0" algn="ctr">
               <a:buNone/>
             </a:pPr>
+            <a:r>
+              <a:rPr lang="en-US" sz="1600" dirty="0">
+                <a:solidFill>
+                  <a:srgbClr val="000000"/>
+                </a:solidFill>
+              </a:rPr>
+              <a:t>✨</a:t>
+            </a:r>
             <a:endParaRPr lang="en-US" sz="1600" dirty="0"/>
           </a:p>
         </p:txBody>
@@ -1331,7 +1594,7 @@
         <p:spPr>
           <a:xfrm>
             <a:off x="0" y="0"/>
-            <a:ext cx="12188952" cy="1737360"/>
+            <a:ext cx="12188952" cy="1188720"/>
           </a:xfrm>
           <a:prstGeom prst="rect">
             <a:avLst/>
@@ -1350,8 +1613,8 @@
         </p:nvSpPr>
         <p:spPr>
           <a:xfrm>
-            <a:off x="548640" y="365760"/>
-            <a:ext cx="1005840" cy="1005840"/>
+            <a:off x="457200" y="228600"/>
+            <a:ext cx="731520" cy="731520"/>
           </a:xfrm>
           <a:prstGeom prst="ellipse">
             <a:avLst/>
@@ -1370,8 +1633,8 @@
         </p:nvSpPr>
         <p:spPr>
           <a:xfrm>
-            <a:off x="548640" y="365760"/>
-            <a:ext cx="1005840" cy="1005840"/>
+            <a:off x="457200" y="228600"/>
+            <a:ext cx="731520" cy="731520"/>
           </a:xfrm>
           <a:prstGeom prst="rect">
             <a:avLst/>
@@ -1387,14 +1650,14 @@
               <a:buNone/>
             </a:pPr>
             <a:r>
-              <a:rPr lang="en-US" sz="2900" dirty="0">
+              <a:rPr lang="en-US" sz="2100" dirty="0">
                 <a:solidFill>
                   <a:srgbClr val="000000"/>
                 </a:solidFill>
               </a:rPr>
-              <a:t>✈️</a:t>
-            </a:r>
-            <a:endParaRPr lang="en-US" sz="2900" dirty="0"/>
+              <a:t>🎬</a:t>
+            </a:r>
+            <a:endParaRPr lang="en-US" sz="2100" dirty="0"/>
           </a:p>
         </p:txBody>
       </p:sp>
@@ -1406,8 +1669,8 @@
         </p:nvSpPr>
         <p:spPr>
           <a:xfrm>
-            <a:off x="1737360" y="320040"/>
-            <a:ext cx="9601200" cy="1097280"/>
+            <a:off x="1371600" y="182880"/>
+            <a:ext cx="9601200" cy="822960"/>
           </a:xfrm>
           <a:prstGeom prst="rect">
             <a:avLst/>
@@ -1423,7 +1686,7 @@
               <a:buNone/>
             </a:pPr>
             <a:r>
-              <a:rPr lang="en-US" sz="3400" b="1" dirty="0">
+              <a:rPr lang="en-US" sz="2400" b="1" dirty="0">
                 <a:solidFill>
                   <a:srgbClr val="FFFFFF"/>
                 </a:solidFill>
@@ -1431,22 +1694,100 @@
                 <a:ea typeface="Cambria" pitchFamily="34" charset="-122"/>
                 <a:cs typeface="Cambria" pitchFamily="34" charset="-120"/>
               </a:rPr>
-              <a:t>Trip Planner</a:t>
-            </a:r>
-            <a:endParaRPr lang="en-US" sz="3400" dirty="0"/>
-          </a:p>
-        </p:txBody>
-      </p:sp>
-      <p:sp>
-        <p:nvSpPr>
-          <p:cNvPr id="6" name="Text 4"/>
-          <p:cNvSpPr txBox="1"/>
-          <p:nvPr/>
-        </p:nvSpPr>
-        <p:spPr>
-          <a:xfrm>
-            <a:off x="640080" y="2057400"/>
-            <a:ext cx="10881360" cy="457200"/>
+              <a:t>TV &amp; Movies Tracker</a:t>
+            </a:r>
+            <a:endParaRPr lang="en-US" sz="2400" dirty="0"/>
+          </a:p>
+        </p:txBody>
+      </p:sp>
+      <p:sp>
+        <p:nvSpPr>
+          <p:cNvPr id="6" name="Shape 4"/>
+          <p:cNvSpPr/>
+          <p:nvPr/>
+        </p:nvSpPr>
+        <p:spPr>
+          <a:xfrm>
+            <a:off x="640080" y="1737360"/>
+            <a:ext cx="5257800" cy="4297680"/>
+          </a:xfrm>
+          <a:prstGeom prst="roundRect">
+            <a:avLst>
+              <a:gd name="adj" fmla="val 2128"/>
+            </a:avLst>
+          </a:prstGeom>
+          <a:solidFill>
+            <a:srgbClr val="FFF3E8"/>
+          </a:solidFill>
+          <a:ln/>
+        </p:spPr>
+      </p:sp>
+      <p:sp>
+        <p:nvSpPr>
+          <p:cNvPr id="7" name="Shape 5"/>
+          <p:cNvSpPr/>
+          <p:nvPr/>
+        </p:nvSpPr>
+        <p:spPr>
+          <a:xfrm>
+            <a:off x="1005840" y="2103120"/>
+            <a:ext cx="640080" cy="640080"/>
+          </a:xfrm>
+          <a:prstGeom prst="ellipse">
+            <a:avLst/>
+          </a:prstGeom>
+          <a:solidFill>
+            <a:srgbClr val="F77F00"/>
+          </a:solidFill>
+          <a:ln/>
+        </p:spPr>
+      </p:sp>
+      <p:sp>
+        <p:nvSpPr>
+          <p:cNvPr id="8" name="Text 6"/>
+          <p:cNvSpPr txBox="1"/>
+          <p:nvPr/>
+        </p:nvSpPr>
+        <p:spPr>
+          <a:xfrm>
+            <a:off x="1005840" y="2103120"/>
+            <a:ext cx="640080" cy="640080"/>
+          </a:xfrm>
+          <a:prstGeom prst="rect">
+            <a:avLst/>
+          </a:prstGeom>
+          <a:noFill/>
+          <a:ln/>
+        </p:spPr>
+        <p:txBody>
+          <a:bodyPr wrap="square" lIns="0" tIns="0" rIns="0" bIns="0" rtlCol="0" anchor="ctr"/>
+          <a:lstStyle/>
+          <a:p>
+            <a:pPr marL="0" indent="0" algn="ctr">
+              <a:buNone/>
+            </a:pPr>
+            <a:r>
+              <a:rPr lang="en-US" sz="1800" dirty="0">
+                <a:solidFill>
+                  <a:srgbClr val="000000"/>
+                </a:solidFill>
+              </a:rPr>
+              <a:t>🎯</a:t>
+            </a:r>
+            <a:endParaRPr lang="en-US" sz="1800" dirty="0"/>
+          </a:p>
+        </p:txBody>
+      </p:sp>
+      <p:sp>
+        <p:nvSpPr>
+          <p:cNvPr id="9" name="Text 7"/>
+          <p:cNvSpPr txBox="1"/>
+          <p:nvPr/>
+        </p:nvSpPr>
+        <p:spPr>
+          <a:xfrm>
+            <a:off x="1828800" y="2148840"/>
+            <a:ext cx="3794760" cy="548640"/>
           </a:xfrm>
           <a:prstGeom prst="rect">
             <a:avLst/>
@@ -1462,30 +1803,189 @@
               <a:buNone/>
             </a:pPr>
             <a:r>
-              <a:rPr lang="en-US" sz="1600" b="1" dirty="0">
-                <a:solidFill>
-                  <a:srgbClr val="F77F00"/>
+              <a:rPr lang="en-US" sz="2000" b="1" dirty="0">
+                <a:solidFill>
+                  <a:srgbClr val="2B1B12"/>
+                </a:solidFill>
+                <a:latin typeface="Cambria" pitchFamily="34" charset="0"/>
+                <a:ea typeface="Cambria" pitchFamily="34" charset="-122"/>
+                <a:cs typeface="Cambria" pitchFamily="34" charset="-120"/>
+              </a:rPr>
+              <a:t>Target Audience</a:t>
+            </a:r>
+            <a:endParaRPr lang="en-US" sz="2000" dirty="0"/>
+          </a:p>
+        </p:txBody>
+      </p:sp>
+      <p:sp>
+        <p:nvSpPr>
+          <p:cNvPr id="10" name="Text 8"/>
+          <p:cNvSpPr txBox="1"/>
+          <p:nvPr/>
+        </p:nvSpPr>
+        <p:spPr>
+          <a:xfrm>
+            <a:off x="1005840" y="2971800"/>
+            <a:ext cx="4526280" cy="2743200"/>
+          </a:xfrm>
+          <a:prstGeom prst="rect">
+            <a:avLst/>
+          </a:prstGeom>
+          <a:noFill/>
+          <a:ln/>
+        </p:spPr>
+        <p:txBody>
+          <a:bodyPr wrap="square" lIns="0" tIns="0" rIns="0" bIns="0" rtlCol="0" anchor="ctr"/>
+          <a:lstStyle/>
+          <a:p>
+            <a:pPr marL="0" indent="0">
+              <a:lnSpc>
+                <a:spcPct val="130000"/>
+              </a:lnSpc>
+              <a:buNone/>
+            </a:pPr>
+            <a:r>
+              <a:rPr lang="en-US" sz="1500" dirty="0">
+                <a:solidFill>
+                  <a:srgbClr val="2B1B12"/>
                 </a:solidFill>
                 <a:latin typeface="Calibri" pitchFamily="34" charset="0"/>
                 <a:ea typeface="Calibri" pitchFamily="34" charset="-122"/>
                 <a:cs typeface="Calibri" pitchFamily="34" charset="-120"/>
               </a:rPr>
-              <a:t>What it does</a:t>
-            </a:r>
-            <a:endParaRPr lang="en-US" sz="1600" dirty="0"/>
-          </a:p>
-        </p:txBody>
-      </p:sp>
-      <p:sp>
-        <p:nvSpPr>
-          <p:cNvPr id="7" name="Text 5"/>
-          <p:cNvSpPr txBox="1"/>
-          <p:nvPr/>
-        </p:nvSpPr>
-        <p:spPr>
-          <a:xfrm>
-            <a:off x="640080" y="2514600"/>
-            <a:ext cx="10881360" cy="822960"/>
+              <a:t>People who watch a lot of shows and movies and lose track of what they've seen casual binge-watchers, students unwinding between classes, and anyone tired of scrolling for 20 minutes before picking something to watch.</a:t>
+            </a:r>
+            <a:endParaRPr lang="en-US" sz="1500" dirty="0"/>
+          </a:p>
+        </p:txBody>
+      </p:sp>
+      <p:sp>
+        <p:nvSpPr>
+          <p:cNvPr id="11" name="Shape 9"/>
+          <p:cNvSpPr/>
+          <p:nvPr/>
+        </p:nvSpPr>
+        <p:spPr>
+          <a:xfrm>
+            <a:off x="6263640" y="1737360"/>
+            <a:ext cx="5257800" cy="4297680"/>
+          </a:xfrm>
+          <a:prstGeom prst="roundRect">
+            <a:avLst>
+              <a:gd name="adj" fmla="val 2128"/>
+            </a:avLst>
+          </a:prstGeom>
+          <a:solidFill>
+            <a:srgbClr val="FFF3E8"/>
+          </a:solidFill>
+          <a:ln/>
+        </p:spPr>
+      </p:sp>
+      <p:sp>
+        <p:nvSpPr>
+          <p:cNvPr id="12" name="Shape 10"/>
+          <p:cNvSpPr/>
+          <p:nvPr/>
+        </p:nvSpPr>
+        <p:spPr>
+          <a:xfrm>
+            <a:off x="6629400" y="2103120"/>
+            <a:ext cx="640080" cy="640080"/>
+          </a:xfrm>
+          <a:prstGeom prst="ellipse">
+            <a:avLst/>
+          </a:prstGeom>
+          <a:solidFill>
+            <a:srgbClr val="FFBA08"/>
+          </a:solidFill>
+          <a:ln/>
+        </p:spPr>
+      </p:sp>
+      <p:sp>
+        <p:nvSpPr>
+          <p:cNvPr id="13" name="Text 11"/>
+          <p:cNvSpPr txBox="1"/>
+          <p:nvPr/>
+        </p:nvSpPr>
+        <p:spPr>
+          <a:xfrm>
+            <a:off x="6629400" y="2103120"/>
+            <a:ext cx="640080" cy="640080"/>
+          </a:xfrm>
+          <a:prstGeom prst="rect">
+            <a:avLst/>
+          </a:prstGeom>
+          <a:noFill/>
+          <a:ln/>
+        </p:spPr>
+        <p:txBody>
+          <a:bodyPr wrap="square" lIns="0" tIns="0" rIns="0" bIns="0" rtlCol="0" anchor="ctr"/>
+          <a:lstStyle/>
+          <a:p>
+            <a:pPr marL="0" indent="0" algn="ctr">
+              <a:buNone/>
+            </a:pPr>
+            <a:r>
+              <a:rPr lang="en-US" sz="1800" dirty="0">
+                <a:solidFill>
+                  <a:srgbClr val="000000"/>
+                </a:solidFill>
+              </a:rPr>
+              <a:t>💡</a:t>
+            </a:r>
+            <a:endParaRPr lang="en-US" sz="1800" dirty="0"/>
+          </a:p>
+        </p:txBody>
+      </p:sp>
+      <p:sp>
+        <p:nvSpPr>
+          <p:cNvPr id="14" name="Text 12"/>
+          <p:cNvSpPr txBox="1"/>
+          <p:nvPr/>
+        </p:nvSpPr>
+        <p:spPr>
+          <a:xfrm>
+            <a:off x="7452360" y="2148840"/>
+            <a:ext cx="3794760" cy="548640"/>
+          </a:xfrm>
+          <a:prstGeom prst="rect">
+            <a:avLst/>
+          </a:prstGeom>
+          <a:noFill/>
+          <a:ln/>
+        </p:spPr>
+        <p:txBody>
+          <a:bodyPr wrap="square" lIns="0" tIns="0" rIns="0" bIns="0" rtlCol="0" anchor="ctr"/>
+          <a:lstStyle/>
+          <a:p>
+            <a:pPr marL="0" indent="0">
+              <a:buNone/>
+            </a:pPr>
+            <a:r>
+              <a:rPr lang="en-US" sz="2000" b="1" dirty="0">
+                <a:solidFill>
+                  <a:srgbClr val="2B1B12"/>
+                </a:solidFill>
+                <a:latin typeface="Cambria" pitchFamily="34" charset="0"/>
+                <a:ea typeface="Cambria" pitchFamily="34" charset="-122"/>
+                <a:cs typeface="Cambria" pitchFamily="34" charset="-120"/>
+              </a:rPr>
+              <a:t>Added Value</a:t>
+            </a:r>
+            <a:endParaRPr lang="en-US" sz="2000" dirty="0"/>
+          </a:p>
+        </p:txBody>
+      </p:sp>
+      <p:sp>
+        <p:nvSpPr>
+          <p:cNvPr id="15" name="Text 13"/>
+          <p:cNvSpPr txBox="1"/>
+          <p:nvPr/>
+        </p:nvSpPr>
+        <p:spPr>
+          <a:xfrm>
+            <a:off x="6629400" y="2971800"/>
+            <a:ext cx="4526280" cy="2743200"/>
           </a:xfrm>
           <a:prstGeom prst="rect">
             <a:avLst/>
@@ -1499,12 +1999,12 @@
           <a:p>
             <a:pPr marL="0" indent="0">
               <a:lnSpc>
-                <a:spcPct val="120000"/>
+                <a:spcPct val="130000"/>
               </a:lnSpc>
               <a:buNone/>
             </a:pPr>
             <a:r>
-              <a:rPr lang="en-US" sz="2000" dirty="0">
+              <a:rPr lang="en-US" sz="1500" dirty="0">
                 <a:solidFill>
                   <a:srgbClr val="2B1B12"/>
                 </a:solidFill>
@@ -1512,282 +2012,9 @@
                 <a:ea typeface="Calibri" pitchFamily="34" charset="-122"/>
                 <a:cs typeface="Calibri" pitchFamily="34" charset="-120"/>
               </a:rPr>
-              <a:t>An app that helps you plan and organize your whole trip.</a:t>
-            </a:r>
-            <a:endParaRPr lang="en-US" sz="2000" dirty="0"/>
-          </a:p>
-        </p:txBody>
-      </p:sp>
-      <p:sp>
-        <p:nvSpPr>
-          <p:cNvPr id="8" name="Text 6"/>
-          <p:cNvSpPr txBox="1"/>
-          <p:nvPr/>
-        </p:nvSpPr>
-        <p:spPr>
-          <a:xfrm>
-            <a:off x="640080" y="3520440"/>
-            <a:ext cx="10881360" cy="457200"/>
-          </a:xfrm>
-          <a:prstGeom prst="rect">
-            <a:avLst/>
-          </a:prstGeom>
-          <a:noFill/>
-          <a:ln/>
-        </p:spPr>
-        <p:txBody>
-          <a:bodyPr wrap="square" lIns="0" tIns="0" rIns="0" bIns="0" rtlCol="0" anchor="ctr"/>
-          <a:lstStyle/>
-          <a:p>
-            <a:pPr marL="0" indent="0">
-              <a:buNone/>
-            </a:pPr>
-            <a:r>
-              <a:rPr lang="en-US" sz="1600" b="1" dirty="0">
-                <a:solidFill>
-                  <a:srgbClr val="F77F00"/>
-                </a:solidFill>
-                <a:latin typeface="Calibri" pitchFamily="34" charset="0"/>
-                <a:ea typeface="Calibri" pitchFamily="34" charset="-122"/>
-                <a:cs typeface="Calibri" pitchFamily="34" charset="-120"/>
-              </a:rPr>
-              <a:t>How I'll use AI</a:t>
-            </a:r>
-            <a:endParaRPr lang="en-US" sz="1600" dirty="0"/>
-          </a:p>
-        </p:txBody>
-      </p:sp>
-      <p:sp>
-        <p:nvSpPr>
-          <p:cNvPr id="9" name="Shape 7"/>
-          <p:cNvSpPr/>
-          <p:nvPr/>
-        </p:nvSpPr>
-        <p:spPr>
-          <a:xfrm>
-            <a:off x="640080" y="3977640"/>
-            <a:ext cx="10881360" cy="868680"/>
-          </a:xfrm>
-          <a:prstGeom prst="roundRect">
-            <a:avLst>
-              <a:gd name="adj" fmla="val 8421"/>
-            </a:avLst>
-          </a:prstGeom>
-          <a:solidFill>
-            <a:srgbClr val="FFF3E8"/>
-          </a:solidFill>
-          <a:ln/>
-        </p:spPr>
-      </p:sp>
-      <p:sp>
-        <p:nvSpPr>
-          <p:cNvPr id="10" name="Shape 8"/>
-          <p:cNvSpPr/>
-          <p:nvPr/>
-        </p:nvSpPr>
-        <p:spPr>
-          <a:xfrm>
-            <a:off x="868680" y="4137660"/>
-            <a:ext cx="548640" cy="548640"/>
-          </a:xfrm>
-          <a:prstGeom prst="ellipse">
-            <a:avLst/>
-          </a:prstGeom>
-          <a:solidFill>
-            <a:srgbClr val="FFBA08"/>
-          </a:solidFill>
-          <a:ln/>
-        </p:spPr>
-      </p:sp>
-      <p:sp>
-        <p:nvSpPr>
-          <p:cNvPr id="11" name="Text 9"/>
-          <p:cNvSpPr txBox="1"/>
-          <p:nvPr/>
-        </p:nvSpPr>
-        <p:spPr>
-          <a:xfrm>
-            <a:off x="868680" y="4137660"/>
-            <a:ext cx="548640" cy="548640"/>
-          </a:xfrm>
-          <a:prstGeom prst="rect">
-            <a:avLst/>
-          </a:prstGeom>
-          <a:noFill/>
-          <a:ln/>
-        </p:spPr>
-        <p:txBody>
-          <a:bodyPr wrap="square" lIns="0" tIns="0" rIns="0" bIns="0" rtlCol="0" anchor="ctr"/>
-          <a:lstStyle/>
-          <a:p>
-            <a:pPr marL="0" indent="0" algn="ctr">
-              <a:buNone/>
-            </a:pPr>
-            <a:r>
-              <a:rPr lang="en-US" sz="1600" dirty="0">
-                <a:solidFill>
-                  <a:srgbClr val="000000"/>
-                </a:solidFill>
-              </a:rPr>
-              <a:t>🧠</a:t>
-            </a:r>
-            <a:endParaRPr lang="en-US" sz="1600" dirty="0"/>
-          </a:p>
-        </p:txBody>
-      </p:sp>
-      <p:sp>
-        <p:nvSpPr>
-          <p:cNvPr id="12" name="Text 10"/>
-          <p:cNvSpPr txBox="1"/>
-          <p:nvPr/>
-        </p:nvSpPr>
-        <p:spPr>
-          <a:xfrm>
-            <a:off x="1691640" y="3977640"/>
-            <a:ext cx="9601200" cy="868680"/>
-          </a:xfrm>
-          <a:prstGeom prst="rect">
-            <a:avLst/>
-          </a:prstGeom>
-          <a:noFill/>
-          <a:ln/>
-        </p:spPr>
-        <p:txBody>
-          <a:bodyPr wrap="square" lIns="0" tIns="0" rIns="0" bIns="0" rtlCol="0" anchor="ctr"/>
-          <a:lstStyle/>
-          <a:p>
-            <a:pPr marL="0" indent="0">
-              <a:buNone/>
-            </a:pPr>
-            <a:r>
-              <a:rPr lang="en-US" sz="1700" dirty="0">
-                <a:solidFill>
-                  <a:srgbClr val="2B1B12"/>
-                </a:solidFill>
-                <a:latin typeface="Calibri" pitchFamily="34" charset="0"/>
-                <a:ea typeface="Calibri" pitchFamily="34" charset="-122"/>
-                <a:cs typeface="Calibri" pitchFamily="34" charset="-120"/>
-              </a:rPr>
-              <a:t>I will use AI to create my trip plan from a simple description.</a:t>
-            </a:r>
-            <a:endParaRPr lang="en-US" sz="1700" dirty="0"/>
-          </a:p>
-        </p:txBody>
-      </p:sp>
-      <p:sp>
-        <p:nvSpPr>
-          <p:cNvPr id="13" name="Shape 11"/>
-          <p:cNvSpPr/>
-          <p:nvPr/>
-        </p:nvSpPr>
-        <p:spPr>
-          <a:xfrm>
-            <a:off x="640080" y="4983480"/>
-            <a:ext cx="10881360" cy="868680"/>
-          </a:xfrm>
-          <a:prstGeom prst="roundRect">
-            <a:avLst>
-              <a:gd name="adj" fmla="val 8421"/>
-            </a:avLst>
-          </a:prstGeom>
-          <a:solidFill>
-            <a:srgbClr val="FFF3E8"/>
-          </a:solidFill>
-          <a:ln/>
-        </p:spPr>
-      </p:sp>
-      <p:sp>
-        <p:nvSpPr>
-          <p:cNvPr id="14" name="Shape 12"/>
-          <p:cNvSpPr/>
-          <p:nvPr/>
-        </p:nvSpPr>
-        <p:spPr>
-          <a:xfrm>
-            <a:off x="868680" y="5143500"/>
-            <a:ext cx="548640" cy="548640"/>
-          </a:xfrm>
-          <a:prstGeom prst="ellipse">
-            <a:avLst/>
-          </a:prstGeom>
-          <a:solidFill>
-            <a:srgbClr val="FFBA08"/>
-          </a:solidFill>
-          <a:ln/>
-        </p:spPr>
-      </p:sp>
-      <p:sp>
-        <p:nvSpPr>
-          <p:cNvPr id="15" name="Text 13"/>
-          <p:cNvSpPr txBox="1"/>
-          <p:nvPr/>
-        </p:nvSpPr>
-        <p:spPr>
-          <a:xfrm>
-            <a:off x="868680" y="5143500"/>
-            <a:ext cx="548640" cy="548640"/>
-          </a:xfrm>
-          <a:prstGeom prst="rect">
-            <a:avLst/>
-          </a:prstGeom>
-          <a:noFill/>
-          <a:ln/>
-        </p:spPr>
-        <p:txBody>
-          <a:bodyPr wrap="square" lIns="0" tIns="0" rIns="0" bIns="0" rtlCol="0" anchor="ctr"/>
-          <a:lstStyle/>
-          <a:p>
-            <a:pPr marL="0" indent="0" algn="ctr">
-              <a:buNone/>
-            </a:pPr>
-            <a:r>
-              <a:rPr lang="en-US" sz="1600" dirty="0">
-                <a:solidFill>
-                  <a:srgbClr val="000000"/>
-                </a:solidFill>
-              </a:rPr>
-              <a:t>🔁</a:t>
-            </a:r>
-            <a:endParaRPr lang="en-US" sz="1600" dirty="0"/>
-          </a:p>
-        </p:txBody>
-      </p:sp>
-      <p:sp>
-        <p:nvSpPr>
-          <p:cNvPr id="16" name="Text 14"/>
-          <p:cNvSpPr txBox="1"/>
-          <p:nvPr/>
-        </p:nvSpPr>
-        <p:spPr>
-          <a:xfrm>
-            <a:off x="1691640" y="4983480"/>
-            <a:ext cx="9601200" cy="868680"/>
-          </a:xfrm>
-          <a:prstGeom prst="rect">
-            <a:avLst/>
-          </a:prstGeom>
-          <a:noFill/>
-          <a:ln/>
-        </p:spPr>
-        <p:txBody>
-          <a:bodyPr wrap="square" lIns="0" tIns="0" rIns="0" bIns="0" rtlCol="0" anchor="ctr"/>
-          <a:lstStyle/>
-          <a:p>
-            <a:pPr marL="0" indent="0">
-              <a:buNone/>
-            </a:pPr>
-            <a:r>
-              <a:rPr lang="en-US" sz="1700" dirty="0">
-                <a:solidFill>
-                  <a:srgbClr val="2B1B12"/>
-                </a:solidFill>
-                <a:latin typeface="Calibri" pitchFamily="34" charset="0"/>
-                <a:ea typeface="Calibri" pitchFamily="34" charset="-122"/>
-                <a:cs typeface="Calibri" pitchFamily="34" charset="-120"/>
-              </a:rPr>
-              <a:t>I will use AI to rearrange my trip plan when something changes.</a:t>
-            </a:r>
-            <a:endParaRPr lang="en-US" sz="1700" dirty="0"/>
+              <a:t>Most trackers just log what you watched. This app understands your taste well enough to recommend the right thing, and it can find a specific movie just from a description no more forgetting a title and giving up the search.</a:t>
+            </a:r>
+            <a:endParaRPr lang="en-US" sz="1500" dirty="0"/>
           </a:p>
         </p:txBody>
       </p:sp>
@@ -1894,7 +2121,7 @@
                   <a:srgbClr val="000000"/>
                 </a:solidFill>
               </a:rPr>
-              <a:t>🍳</a:t>
+              <a:t>✈️</a:t>
             </a:r>
             <a:endParaRPr lang="en-US" sz="2900" dirty="0"/>
           </a:p>
@@ -1933,7 +2160,7 @@
                 <a:ea typeface="Cambria" pitchFamily="34" charset="-122"/>
                 <a:cs typeface="Cambria" pitchFamily="34" charset="-120"/>
               </a:rPr>
-              <a:t>Meal Planner</a:t>
+              <a:t>Trip Planner</a:t>
             </a:r>
             <a:endParaRPr lang="en-US" sz="3400" dirty="0"/>
           </a:p>
@@ -2014,7 +2241,7 @@
                 <a:ea typeface="Calibri" pitchFamily="34" charset="-122"/>
                 <a:cs typeface="Calibri" pitchFamily="34" charset="-120"/>
               </a:rPr>
-              <a:t>An app that finds recipes using food you already have, and helps you reach your health goals.</a:t>
+              <a:t>An app that helps you plan and organize your whole trip.</a:t>
             </a:r>
             <a:endParaRPr lang="en-US" sz="2000" dirty="0"/>
           </a:p>
@@ -2131,7 +2358,7 @@
                   <a:srgbClr val="000000"/>
                 </a:solidFill>
               </a:rPr>
-              <a:t>👨‍🍳</a:t>
+              <a:t>🧠</a:t>
             </a:r>
             <a:endParaRPr lang="en-US" sz="1600" dirty="0"/>
           </a:p>
@@ -2170,9 +2397,1443 @@
                 <a:ea typeface="Calibri" pitchFamily="34" charset="-122"/>
                 <a:cs typeface="Calibri" pitchFamily="34" charset="-120"/>
               </a:rPr>
+              <a:t>I will use AI to create my trip plan from a simple description.</a:t>
+            </a:r>
+            <a:endParaRPr lang="en-US" sz="1700" dirty="0"/>
+          </a:p>
+        </p:txBody>
+      </p:sp>
+      <p:sp>
+        <p:nvSpPr>
+          <p:cNvPr id="13" name="Shape 11"/>
+          <p:cNvSpPr/>
+          <p:nvPr/>
+        </p:nvSpPr>
+        <p:spPr>
+          <a:xfrm>
+            <a:off x="640080" y="4983480"/>
+            <a:ext cx="10881360" cy="868680"/>
+          </a:xfrm>
+          <a:prstGeom prst="roundRect">
+            <a:avLst>
+              <a:gd name="adj" fmla="val 8421"/>
+            </a:avLst>
+          </a:prstGeom>
+          <a:solidFill>
+            <a:srgbClr val="FFF3E8"/>
+          </a:solidFill>
+          <a:ln/>
+        </p:spPr>
+      </p:sp>
+      <p:sp>
+        <p:nvSpPr>
+          <p:cNvPr id="14" name="Shape 12"/>
+          <p:cNvSpPr/>
+          <p:nvPr/>
+        </p:nvSpPr>
+        <p:spPr>
+          <a:xfrm>
+            <a:off x="868680" y="5143500"/>
+            <a:ext cx="548640" cy="548640"/>
+          </a:xfrm>
+          <a:prstGeom prst="ellipse">
+            <a:avLst/>
+          </a:prstGeom>
+          <a:solidFill>
+            <a:srgbClr val="FFBA08"/>
+          </a:solidFill>
+          <a:ln/>
+        </p:spPr>
+      </p:sp>
+      <p:sp>
+        <p:nvSpPr>
+          <p:cNvPr id="15" name="Text 13"/>
+          <p:cNvSpPr txBox="1"/>
+          <p:nvPr/>
+        </p:nvSpPr>
+        <p:spPr>
+          <a:xfrm>
+            <a:off x="868680" y="5143500"/>
+            <a:ext cx="548640" cy="548640"/>
+          </a:xfrm>
+          <a:prstGeom prst="rect">
+            <a:avLst/>
+          </a:prstGeom>
+          <a:noFill/>
+          <a:ln/>
+        </p:spPr>
+        <p:txBody>
+          <a:bodyPr wrap="square" lIns="0" tIns="0" rIns="0" bIns="0" rtlCol="0" anchor="ctr"/>
+          <a:lstStyle/>
+          <a:p>
+            <a:pPr marL="0" indent="0" algn="ctr">
+              <a:buNone/>
+            </a:pPr>
+            <a:r>
+              <a:rPr lang="en-US" sz="1600" dirty="0">
+                <a:solidFill>
+                  <a:srgbClr val="000000"/>
+                </a:solidFill>
+              </a:rPr>
+              <a:t>🔁</a:t>
+            </a:r>
+            <a:endParaRPr lang="en-US" sz="1600" dirty="0"/>
+          </a:p>
+        </p:txBody>
+      </p:sp>
+      <p:sp>
+        <p:nvSpPr>
+          <p:cNvPr id="16" name="Text 14"/>
+          <p:cNvSpPr txBox="1"/>
+          <p:nvPr/>
+        </p:nvSpPr>
+        <p:spPr>
+          <a:xfrm>
+            <a:off x="1691640" y="4983480"/>
+            <a:ext cx="9601200" cy="868680"/>
+          </a:xfrm>
+          <a:prstGeom prst="rect">
+            <a:avLst/>
+          </a:prstGeom>
+          <a:noFill/>
+          <a:ln/>
+        </p:spPr>
+        <p:txBody>
+          <a:bodyPr wrap="square" lIns="0" tIns="0" rIns="0" bIns="0" rtlCol="0" anchor="ctr"/>
+          <a:lstStyle/>
+          <a:p>
+            <a:pPr marL="0" indent="0">
+              <a:buNone/>
+            </a:pPr>
+            <a:r>
+              <a:rPr lang="en-US" sz="1700" dirty="0">
+                <a:solidFill>
+                  <a:srgbClr val="2B1B12"/>
+                </a:solidFill>
+                <a:latin typeface="Calibri" pitchFamily="34" charset="0"/>
+                <a:ea typeface="Calibri" pitchFamily="34" charset="-122"/>
+                <a:cs typeface="Calibri" pitchFamily="34" charset="-120"/>
+              </a:rPr>
+              <a:t>I will use AI to rearrange my trip plan when something changes.</a:t>
+            </a:r>
+            <a:endParaRPr lang="en-US" sz="1700" dirty="0"/>
+          </a:p>
+        </p:txBody>
+      </p:sp>
+    </p:spTree>
+  </p:cSld>
+  <p:clrMapOvr>
+    <a:masterClrMapping/>
+  </p:clrMapOvr>
+</p:sld>
+</file>
+
+<file path=ppt/slides/slide4.xml><?xml version="1.0" encoding="utf-8"?>
+<p:sld xmlns:a="http://schemas.openxmlformats.org/drawingml/2006/main" xmlns:r="http://schemas.openxmlformats.org/officeDocument/2006/relationships" xmlns:p="http://schemas.openxmlformats.org/presentationml/2006/main">
+  <p:cSld name="Slide 4">
+    <p:bg>
+      <p:bgPr>
+        <a:solidFill>
+          <a:srgbClr val="FFFFFF"/>
+        </a:solidFill>
+        <a:effectLst/>
+      </p:bgPr>
+    </p:bg>
+    <p:spTree>
+      <p:nvGrpSpPr>
+        <p:cNvPr id="1" name=""/>
+        <p:cNvGrpSpPr/>
+        <p:nvPr/>
+      </p:nvGrpSpPr>
+      <p:grpSpPr>
+        <a:xfrm>
+          <a:off x="0" y="0"/>
+          <a:ext cx="0" cy="0"/>
+          <a:chOff x="0" y="0"/>
+          <a:chExt cx="0" cy="0"/>
+        </a:xfrm>
+      </p:grpSpPr>
+      <p:sp>
+        <p:nvSpPr>
+          <p:cNvPr id="2" name="Shape 0"/>
+          <p:cNvSpPr/>
+          <p:nvPr/>
+        </p:nvSpPr>
+        <p:spPr>
+          <a:xfrm>
+            <a:off x="0" y="0"/>
+            <a:ext cx="12188952" cy="1188720"/>
+          </a:xfrm>
+          <a:prstGeom prst="rect">
+            <a:avLst/>
+          </a:prstGeom>
+          <a:solidFill>
+            <a:srgbClr val="D84315"/>
+          </a:solidFill>
+          <a:ln/>
+        </p:spPr>
+      </p:sp>
+      <p:sp>
+        <p:nvSpPr>
+          <p:cNvPr id="3" name="Shape 1"/>
+          <p:cNvSpPr/>
+          <p:nvPr/>
+        </p:nvSpPr>
+        <p:spPr>
+          <a:xfrm>
+            <a:off x="457200" y="228600"/>
+            <a:ext cx="731520" cy="731520"/>
+          </a:xfrm>
+          <a:prstGeom prst="ellipse">
+            <a:avLst/>
+          </a:prstGeom>
+          <a:solidFill>
+            <a:srgbClr val="FFFFFF"/>
+          </a:solidFill>
+          <a:ln/>
+        </p:spPr>
+      </p:sp>
+      <p:sp>
+        <p:nvSpPr>
+          <p:cNvPr id="4" name="Text 2"/>
+          <p:cNvSpPr txBox="1"/>
+          <p:nvPr/>
+        </p:nvSpPr>
+        <p:spPr>
+          <a:xfrm>
+            <a:off x="457200" y="228600"/>
+            <a:ext cx="731520" cy="731520"/>
+          </a:xfrm>
+          <a:prstGeom prst="rect">
+            <a:avLst/>
+          </a:prstGeom>
+          <a:noFill/>
+          <a:ln/>
+        </p:spPr>
+        <p:txBody>
+          <a:bodyPr wrap="square" lIns="0" tIns="0" rIns="0" bIns="0" rtlCol="0" anchor="ctr"/>
+          <a:lstStyle/>
+          <a:p>
+            <a:pPr marL="0" indent="0" algn="ctr">
+              <a:buNone/>
+            </a:pPr>
+            <a:r>
+              <a:rPr lang="en-US" sz="2100" dirty="0">
+                <a:solidFill>
+                  <a:srgbClr val="000000"/>
+                </a:solidFill>
+              </a:rPr>
+              <a:t>✈️</a:t>
+            </a:r>
+            <a:endParaRPr lang="en-US" sz="2100" dirty="0"/>
+          </a:p>
+        </p:txBody>
+      </p:sp>
+      <p:sp>
+        <p:nvSpPr>
+          <p:cNvPr id="5" name="Text 3"/>
+          <p:cNvSpPr txBox="1"/>
+          <p:nvPr/>
+        </p:nvSpPr>
+        <p:spPr>
+          <a:xfrm>
+            <a:off x="1371600" y="182880"/>
+            <a:ext cx="9601200" cy="822960"/>
+          </a:xfrm>
+          <a:prstGeom prst="rect">
+            <a:avLst/>
+          </a:prstGeom>
+          <a:noFill/>
+          <a:ln/>
+        </p:spPr>
+        <p:txBody>
+          <a:bodyPr wrap="square" lIns="0" tIns="0" rIns="0" bIns="0" rtlCol="0" anchor="ctr"/>
+          <a:lstStyle/>
+          <a:p>
+            <a:pPr marL="0" indent="0">
+              <a:buNone/>
+            </a:pPr>
+            <a:r>
+              <a:rPr lang="en-US" sz="2400" b="1" dirty="0">
+                <a:solidFill>
+                  <a:srgbClr val="FFFFFF"/>
+                </a:solidFill>
+                <a:latin typeface="Cambria" pitchFamily="34" charset="0"/>
+                <a:ea typeface="Cambria" pitchFamily="34" charset="-122"/>
+                <a:cs typeface="Cambria" pitchFamily="34" charset="-120"/>
+              </a:rPr>
+              <a:t>Trip Planner</a:t>
+            </a:r>
+            <a:endParaRPr lang="en-US" sz="2400" dirty="0"/>
+          </a:p>
+        </p:txBody>
+      </p:sp>
+      <p:sp>
+        <p:nvSpPr>
+          <p:cNvPr id="6" name="Shape 4"/>
+          <p:cNvSpPr/>
+          <p:nvPr/>
+        </p:nvSpPr>
+        <p:spPr>
+          <a:xfrm>
+            <a:off x="640080" y="1737360"/>
+            <a:ext cx="5257800" cy="4297680"/>
+          </a:xfrm>
+          <a:prstGeom prst="roundRect">
+            <a:avLst>
+              <a:gd name="adj" fmla="val 2128"/>
+            </a:avLst>
+          </a:prstGeom>
+          <a:solidFill>
+            <a:srgbClr val="FFF3E8"/>
+          </a:solidFill>
+          <a:ln/>
+        </p:spPr>
+      </p:sp>
+      <p:sp>
+        <p:nvSpPr>
+          <p:cNvPr id="7" name="Shape 5"/>
+          <p:cNvSpPr/>
+          <p:nvPr/>
+        </p:nvSpPr>
+        <p:spPr>
+          <a:xfrm>
+            <a:off x="1005840" y="2103120"/>
+            <a:ext cx="640080" cy="640080"/>
+          </a:xfrm>
+          <a:prstGeom prst="ellipse">
+            <a:avLst/>
+          </a:prstGeom>
+          <a:solidFill>
+            <a:srgbClr val="F77F00"/>
+          </a:solidFill>
+          <a:ln/>
+        </p:spPr>
+      </p:sp>
+      <p:sp>
+        <p:nvSpPr>
+          <p:cNvPr id="8" name="Text 6"/>
+          <p:cNvSpPr txBox="1"/>
+          <p:nvPr/>
+        </p:nvSpPr>
+        <p:spPr>
+          <a:xfrm>
+            <a:off x="1005840" y="2103120"/>
+            <a:ext cx="640080" cy="640080"/>
+          </a:xfrm>
+          <a:prstGeom prst="rect">
+            <a:avLst/>
+          </a:prstGeom>
+          <a:noFill/>
+          <a:ln/>
+        </p:spPr>
+        <p:txBody>
+          <a:bodyPr wrap="square" lIns="0" tIns="0" rIns="0" bIns="0" rtlCol="0" anchor="ctr"/>
+          <a:lstStyle/>
+          <a:p>
+            <a:pPr marL="0" indent="0" algn="ctr">
+              <a:buNone/>
+            </a:pPr>
+            <a:r>
+              <a:rPr lang="en-US" sz="1800" dirty="0">
+                <a:solidFill>
+                  <a:srgbClr val="000000"/>
+                </a:solidFill>
+              </a:rPr>
+              <a:t>🎯</a:t>
+            </a:r>
+            <a:endParaRPr lang="en-US" sz="1800" dirty="0"/>
+          </a:p>
+        </p:txBody>
+      </p:sp>
+      <p:sp>
+        <p:nvSpPr>
+          <p:cNvPr id="9" name="Text 7"/>
+          <p:cNvSpPr txBox="1"/>
+          <p:nvPr/>
+        </p:nvSpPr>
+        <p:spPr>
+          <a:xfrm>
+            <a:off x="1828800" y="2148840"/>
+            <a:ext cx="3794760" cy="548640"/>
+          </a:xfrm>
+          <a:prstGeom prst="rect">
+            <a:avLst/>
+          </a:prstGeom>
+          <a:noFill/>
+          <a:ln/>
+        </p:spPr>
+        <p:txBody>
+          <a:bodyPr wrap="square" lIns="0" tIns="0" rIns="0" bIns="0" rtlCol="0" anchor="ctr"/>
+          <a:lstStyle/>
+          <a:p>
+            <a:pPr marL="0" indent="0">
+              <a:buNone/>
+            </a:pPr>
+            <a:r>
+              <a:rPr lang="en-US" sz="2000" b="1" dirty="0">
+                <a:solidFill>
+                  <a:srgbClr val="2B1B12"/>
+                </a:solidFill>
+                <a:latin typeface="Cambria" pitchFamily="34" charset="0"/>
+                <a:ea typeface="Cambria" pitchFamily="34" charset="-122"/>
+                <a:cs typeface="Cambria" pitchFamily="34" charset="-120"/>
+              </a:rPr>
+              <a:t>Target Audience</a:t>
+            </a:r>
+            <a:endParaRPr lang="en-US" sz="2000" dirty="0"/>
+          </a:p>
+        </p:txBody>
+      </p:sp>
+      <p:sp>
+        <p:nvSpPr>
+          <p:cNvPr id="10" name="Text 8"/>
+          <p:cNvSpPr txBox="1"/>
+          <p:nvPr/>
+        </p:nvSpPr>
+        <p:spPr>
+          <a:xfrm>
+            <a:off x="1005840" y="2971800"/>
+            <a:ext cx="4526280" cy="2743200"/>
+          </a:xfrm>
+          <a:prstGeom prst="rect">
+            <a:avLst/>
+          </a:prstGeom>
+          <a:noFill/>
+          <a:ln/>
+        </p:spPr>
+        <p:txBody>
+          <a:bodyPr wrap="square" lIns="0" tIns="0" rIns="0" bIns="0" rtlCol="0" anchor="ctr"/>
+          <a:lstStyle/>
+          <a:p>
+            <a:pPr marL="0" indent="0">
+              <a:lnSpc>
+                <a:spcPct val="130000"/>
+              </a:lnSpc>
+              <a:buNone/>
+            </a:pPr>
+            <a:r>
+              <a:rPr lang="en-US" sz="1500" dirty="0">
+                <a:solidFill>
+                  <a:srgbClr val="2B1B12"/>
+                </a:solidFill>
+                <a:latin typeface="Calibri" pitchFamily="34" charset="0"/>
+                <a:ea typeface="Calibri" pitchFamily="34" charset="-122"/>
+                <a:cs typeface="Calibri" pitchFamily="34" charset="-120"/>
+              </a:rPr>
+              <a:t>Busy people and students who want a real vacation plan without spending hours researching first-time travelers, people planning short trips, and anyone who wants a plan built for them instead of building it themselves.</a:t>
+            </a:r>
+            <a:endParaRPr lang="en-US" sz="1500" dirty="0"/>
+          </a:p>
+        </p:txBody>
+      </p:sp>
+      <p:sp>
+        <p:nvSpPr>
+          <p:cNvPr id="11" name="Shape 9"/>
+          <p:cNvSpPr/>
+          <p:nvPr/>
+        </p:nvSpPr>
+        <p:spPr>
+          <a:xfrm>
+            <a:off x="6263640" y="1737360"/>
+            <a:ext cx="5257800" cy="4297680"/>
+          </a:xfrm>
+          <a:prstGeom prst="roundRect">
+            <a:avLst>
+              <a:gd name="adj" fmla="val 2128"/>
+            </a:avLst>
+          </a:prstGeom>
+          <a:solidFill>
+            <a:srgbClr val="FFF3E8"/>
+          </a:solidFill>
+          <a:ln/>
+        </p:spPr>
+      </p:sp>
+      <p:sp>
+        <p:nvSpPr>
+          <p:cNvPr id="12" name="Shape 10"/>
+          <p:cNvSpPr/>
+          <p:nvPr/>
+        </p:nvSpPr>
+        <p:spPr>
+          <a:xfrm>
+            <a:off x="6629400" y="2103120"/>
+            <a:ext cx="640080" cy="640080"/>
+          </a:xfrm>
+          <a:prstGeom prst="ellipse">
+            <a:avLst/>
+          </a:prstGeom>
+          <a:solidFill>
+            <a:srgbClr val="FFBA08"/>
+          </a:solidFill>
+          <a:ln/>
+        </p:spPr>
+      </p:sp>
+      <p:sp>
+        <p:nvSpPr>
+          <p:cNvPr id="13" name="Text 11"/>
+          <p:cNvSpPr txBox="1"/>
+          <p:nvPr/>
+        </p:nvSpPr>
+        <p:spPr>
+          <a:xfrm>
+            <a:off x="6629400" y="2103120"/>
+            <a:ext cx="640080" cy="640080"/>
+          </a:xfrm>
+          <a:prstGeom prst="rect">
+            <a:avLst/>
+          </a:prstGeom>
+          <a:noFill/>
+          <a:ln/>
+        </p:spPr>
+        <p:txBody>
+          <a:bodyPr wrap="square" lIns="0" tIns="0" rIns="0" bIns="0" rtlCol="0" anchor="ctr"/>
+          <a:lstStyle/>
+          <a:p>
+            <a:pPr marL="0" indent="0" algn="ctr">
+              <a:buNone/>
+            </a:pPr>
+            <a:r>
+              <a:rPr lang="en-US" sz="1800" dirty="0">
+                <a:solidFill>
+                  <a:srgbClr val="000000"/>
+                </a:solidFill>
+              </a:rPr>
+              <a:t>💡</a:t>
+            </a:r>
+            <a:endParaRPr lang="en-US" sz="1800" dirty="0"/>
+          </a:p>
+        </p:txBody>
+      </p:sp>
+      <p:sp>
+        <p:nvSpPr>
+          <p:cNvPr id="14" name="Text 12"/>
+          <p:cNvSpPr txBox="1"/>
+          <p:nvPr/>
+        </p:nvSpPr>
+        <p:spPr>
+          <a:xfrm>
+            <a:off x="7452360" y="2148840"/>
+            <a:ext cx="3794760" cy="548640"/>
+          </a:xfrm>
+          <a:prstGeom prst="rect">
+            <a:avLst/>
+          </a:prstGeom>
+          <a:noFill/>
+          <a:ln/>
+        </p:spPr>
+        <p:txBody>
+          <a:bodyPr wrap="square" lIns="0" tIns="0" rIns="0" bIns="0" rtlCol="0" anchor="ctr"/>
+          <a:lstStyle/>
+          <a:p>
+            <a:pPr marL="0" indent="0">
+              <a:buNone/>
+            </a:pPr>
+            <a:r>
+              <a:rPr lang="en-US" sz="2000" b="1" dirty="0">
+                <a:solidFill>
+                  <a:srgbClr val="2B1B12"/>
+                </a:solidFill>
+                <a:latin typeface="Cambria" pitchFamily="34" charset="0"/>
+                <a:ea typeface="Cambria" pitchFamily="34" charset="-122"/>
+                <a:cs typeface="Cambria" pitchFamily="34" charset="-120"/>
+              </a:rPr>
+              <a:t>Added Value</a:t>
+            </a:r>
+            <a:endParaRPr lang="en-US" sz="2000" dirty="0"/>
+          </a:p>
+        </p:txBody>
+      </p:sp>
+      <p:sp>
+        <p:nvSpPr>
+          <p:cNvPr id="15" name="Text 13"/>
+          <p:cNvSpPr txBox="1"/>
+          <p:nvPr/>
+        </p:nvSpPr>
+        <p:spPr>
+          <a:xfrm>
+            <a:off x="6629400" y="2971800"/>
+            <a:ext cx="4526280" cy="2743200"/>
+          </a:xfrm>
+          <a:prstGeom prst="rect">
+            <a:avLst/>
+          </a:prstGeom>
+          <a:noFill/>
+          <a:ln/>
+        </p:spPr>
+        <p:txBody>
+          <a:bodyPr wrap="square" lIns="0" tIns="0" rIns="0" bIns="0" rtlCol="0" anchor="ctr"/>
+          <a:lstStyle/>
+          <a:p>
+            <a:pPr marL="0" indent="0">
+              <a:lnSpc>
+                <a:spcPct val="130000"/>
+              </a:lnSpc>
+              <a:buNone/>
+            </a:pPr>
+            <a:r>
+              <a:rPr lang="en-US" sz="1500" dirty="0">
+                <a:solidFill>
+                  <a:srgbClr val="2B1B12"/>
+                </a:solidFill>
+                <a:latin typeface="Calibri" pitchFamily="34" charset="0"/>
+                <a:ea typeface="Calibri" pitchFamily="34" charset="-122"/>
+                <a:cs typeface="Calibri" pitchFamily="34" charset="-120"/>
+              </a:rPr>
+              <a:t>Other trip apps just organize bookings you already made. This one builds the entire day by day plan for you from a single sentence, and instantly rearranges it when something changes no starting over from scratch.</a:t>
+            </a:r>
+            <a:endParaRPr lang="en-US" sz="1500" dirty="0"/>
+          </a:p>
+        </p:txBody>
+      </p:sp>
+    </p:spTree>
+  </p:cSld>
+  <p:clrMapOvr>
+    <a:masterClrMapping/>
+  </p:clrMapOvr>
+</p:sld>
+</file>
+
+<file path=ppt/slides/slide5.xml><?xml version="1.0" encoding="utf-8"?>
+<p:sld xmlns:a="http://schemas.openxmlformats.org/drawingml/2006/main" xmlns:r="http://schemas.openxmlformats.org/officeDocument/2006/relationships" xmlns:p="http://schemas.openxmlformats.org/presentationml/2006/main">
+  <p:cSld name="Slide 5">
+    <p:bg>
+      <p:bgPr>
+        <a:solidFill>
+          <a:srgbClr val="FFFFFF"/>
+        </a:solidFill>
+        <a:effectLst/>
+      </p:bgPr>
+    </p:bg>
+    <p:spTree>
+      <p:nvGrpSpPr>
+        <p:cNvPr id="1" name=""/>
+        <p:cNvGrpSpPr/>
+        <p:nvPr/>
+      </p:nvGrpSpPr>
+      <p:grpSpPr>
+        <a:xfrm>
+          <a:off x="0" y="0"/>
+          <a:ext cx="0" cy="0"/>
+          <a:chOff x="0" y="0"/>
+          <a:chExt cx="0" cy="0"/>
+        </a:xfrm>
+      </p:grpSpPr>
+      <p:sp>
+        <p:nvSpPr>
+          <p:cNvPr id="2" name="Shape 0"/>
+          <p:cNvSpPr/>
+          <p:nvPr/>
+        </p:nvSpPr>
+        <p:spPr>
+          <a:xfrm>
+            <a:off x="0" y="0"/>
+            <a:ext cx="12188952" cy="1737360"/>
+          </a:xfrm>
+          <a:prstGeom prst="rect">
+            <a:avLst/>
+          </a:prstGeom>
+          <a:solidFill>
+            <a:srgbClr val="D84315"/>
+          </a:solidFill>
+          <a:ln/>
+        </p:spPr>
+      </p:sp>
+      <p:sp>
+        <p:nvSpPr>
+          <p:cNvPr id="3" name="Shape 1"/>
+          <p:cNvSpPr/>
+          <p:nvPr/>
+        </p:nvSpPr>
+        <p:spPr>
+          <a:xfrm>
+            <a:off x="548640" y="365760"/>
+            <a:ext cx="1005840" cy="1005840"/>
+          </a:xfrm>
+          <a:prstGeom prst="ellipse">
+            <a:avLst/>
+          </a:prstGeom>
+          <a:solidFill>
+            <a:srgbClr val="FFFFFF"/>
+          </a:solidFill>
+          <a:ln/>
+        </p:spPr>
+      </p:sp>
+      <p:sp>
+        <p:nvSpPr>
+          <p:cNvPr id="4" name="Text 2"/>
+          <p:cNvSpPr txBox="1"/>
+          <p:nvPr/>
+        </p:nvSpPr>
+        <p:spPr>
+          <a:xfrm>
+            <a:off x="548640" y="365760"/>
+            <a:ext cx="1005840" cy="1005840"/>
+          </a:xfrm>
+          <a:prstGeom prst="rect">
+            <a:avLst/>
+          </a:prstGeom>
+          <a:noFill/>
+          <a:ln/>
+        </p:spPr>
+        <p:txBody>
+          <a:bodyPr wrap="square" lIns="0" tIns="0" rIns="0" bIns="0" rtlCol="0" anchor="ctr"/>
+          <a:lstStyle/>
+          <a:p>
+            <a:pPr marL="0" indent="0" algn="ctr">
+              <a:buNone/>
+            </a:pPr>
+            <a:r>
+              <a:rPr lang="en-US" sz="2900" dirty="0">
+                <a:solidFill>
+                  <a:srgbClr val="000000"/>
+                </a:solidFill>
+              </a:rPr>
+              <a:t>🍳</a:t>
+            </a:r>
+            <a:endParaRPr lang="en-US" sz="2900" dirty="0"/>
+          </a:p>
+        </p:txBody>
+      </p:sp>
+      <p:sp>
+        <p:nvSpPr>
+          <p:cNvPr id="5" name="Text 3"/>
+          <p:cNvSpPr txBox="1"/>
+          <p:nvPr/>
+        </p:nvSpPr>
+        <p:spPr>
+          <a:xfrm>
+            <a:off x="1737360" y="320040"/>
+            <a:ext cx="9601200" cy="1097280"/>
+          </a:xfrm>
+          <a:prstGeom prst="rect">
+            <a:avLst/>
+          </a:prstGeom>
+          <a:noFill/>
+          <a:ln/>
+        </p:spPr>
+        <p:txBody>
+          <a:bodyPr wrap="square" lIns="0" tIns="0" rIns="0" bIns="0" rtlCol="0" anchor="ctr"/>
+          <a:lstStyle/>
+          <a:p>
+            <a:pPr marL="0" indent="0">
+              <a:buNone/>
+            </a:pPr>
+            <a:r>
+              <a:rPr lang="en-US" sz="3400" b="1" dirty="0">
+                <a:solidFill>
+                  <a:srgbClr val="FFFFFF"/>
+                </a:solidFill>
+                <a:latin typeface="Cambria" pitchFamily="34" charset="0"/>
+                <a:ea typeface="Cambria" pitchFamily="34" charset="-122"/>
+                <a:cs typeface="Cambria" pitchFamily="34" charset="-120"/>
+              </a:rPr>
+              <a:t>Meal Planner</a:t>
+            </a:r>
+            <a:endParaRPr lang="en-US" sz="3400" dirty="0"/>
+          </a:p>
+        </p:txBody>
+      </p:sp>
+      <p:sp>
+        <p:nvSpPr>
+          <p:cNvPr id="6" name="Text 4"/>
+          <p:cNvSpPr txBox="1"/>
+          <p:nvPr/>
+        </p:nvSpPr>
+        <p:spPr>
+          <a:xfrm>
+            <a:off x="640080" y="2057400"/>
+            <a:ext cx="10881360" cy="457200"/>
+          </a:xfrm>
+          <a:prstGeom prst="rect">
+            <a:avLst/>
+          </a:prstGeom>
+          <a:noFill/>
+          <a:ln/>
+        </p:spPr>
+        <p:txBody>
+          <a:bodyPr wrap="square" lIns="0" tIns="0" rIns="0" bIns="0" rtlCol="0" anchor="ctr"/>
+          <a:lstStyle/>
+          <a:p>
+            <a:pPr marL="0" indent="0">
+              <a:buNone/>
+            </a:pPr>
+            <a:r>
+              <a:rPr lang="en-US" sz="1600" b="1" dirty="0">
+                <a:solidFill>
+                  <a:srgbClr val="F77F00"/>
+                </a:solidFill>
+                <a:latin typeface="Calibri" pitchFamily="34" charset="0"/>
+                <a:ea typeface="Calibri" pitchFamily="34" charset="-122"/>
+                <a:cs typeface="Calibri" pitchFamily="34" charset="-120"/>
+              </a:rPr>
+              <a:t>What it does</a:t>
+            </a:r>
+            <a:endParaRPr lang="en-US" sz="1600" dirty="0"/>
+          </a:p>
+        </p:txBody>
+      </p:sp>
+      <p:sp>
+        <p:nvSpPr>
+          <p:cNvPr id="7" name="Text 5"/>
+          <p:cNvSpPr txBox="1"/>
+          <p:nvPr/>
+        </p:nvSpPr>
+        <p:spPr>
+          <a:xfrm>
+            <a:off x="640080" y="2514600"/>
+            <a:ext cx="10881360" cy="822960"/>
+          </a:xfrm>
+          <a:prstGeom prst="rect">
+            <a:avLst/>
+          </a:prstGeom>
+          <a:noFill/>
+          <a:ln/>
+        </p:spPr>
+        <p:txBody>
+          <a:bodyPr wrap="square" lIns="0" tIns="0" rIns="0" bIns="0" rtlCol="0" anchor="ctr"/>
+          <a:lstStyle/>
+          <a:p>
+            <a:pPr marL="0" indent="0">
+              <a:lnSpc>
+                <a:spcPct val="120000"/>
+              </a:lnSpc>
+              <a:buNone/>
+            </a:pPr>
+            <a:r>
+              <a:rPr lang="en-US" sz="2000" dirty="0">
+                <a:solidFill>
+                  <a:srgbClr val="2B1B12"/>
+                </a:solidFill>
+                <a:latin typeface="Calibri" pitchFamily="34" charset="0"/>
+                <a:ea typeface="Calibri" pitchFamily="34" charset="-122"/>
+                <a:cs typeface="Calibri" pitchFamily="34" charset="-120"/>
+              </a:rPr>
+              <a:t>An app that finds recipes using food you already have, and helps you reach your health goals.</a:t>
+            </a:r>
+            <a:endParaRPr lang="en-US" sz="2000" dirty="0"/>
+          </a:p>
+        </p:txBody>
+      </p:sp>
+      <p:sp>
+        <p:nvSpPr>
+          <p:cNvPr id="8" name="Text 6"/>
+          <p:cNvSpPr txBox="1"/>
+          <p:nvPr/>
+        </p:nvSpPr>
+        <p:spPr>
+          <a:xfrm>
+            <a:off x="640080" y="3520440"/>
+            <a:ext cx="10881360" cy="457200"/>
+          </a:xfrm>
+          <a:prstGeom prst="rect">
+            <a:avLst/>
+          </a:prstGeom>
+          <a:noFill/>
+          <a:ln/>
+        </p:spPr>
+        <p:txBody>
+          <a:bodyPr wrap="square" lIns="0" tIns="0" rIns="0" bIns="0" rtlCol="0" anchor="ctr"/>
+          <a:lstStyle/>
+          <a:p>
+            <a:pPr marL="0" indent="0">
+              <a:buNone/>
+            </a:pPr>
+            <a:r>
+              <a:rPr lang="en-US" sz="1600" b="1" dirty="0">
+                <a:solidFill>
+                  <a:srgbClr val="F77F00"/>
+                </a:solidFill>
+                <a:latin typeface="Calibri" pitchFamily="34" charset="0"/>
+                <a:ea typeface="Calibri" pitchFamily="34" charset="-122"/>
+                <a:cs typeface="Calibri" pitchFamily="34" charset="-120"/>
+              </a:rPr>
+              <a:t>How I'll use AI</a:t>
+            </a:r>
+            <a:endParaRPr lang="en-US" sz="1600" dirty="0"/>
+          </a:p>
+        </p:txBody>
+      </p:sp>
+      <p:sp>
+        <p:nvSpPr>
+          <p:cNvPr id="9" name="Shape 7"/>
+          <p:cNvSpPr/>
+          <p:nvPr/>
+        </p:nvSpPr>
+        <p:spPr>
+          <a:xfrm>
+            <a:off x="640080" y="3977640"/>
+            <a:ext cx="10881360" cy="868680"/>
+          </a:xfrm>
+          <a:prstGeom prst="roundRect">
+            <a:avLst>
+              <a:gd name="adj" fmla="val 8421"/>
+            </a:avLst>
+          </a:prstGeom>
+          <a:solidFill>
+            <a:srgbClr val="FFF3E8"/>
+          </a:solidFill>
+          <a:ln/>
+        </p:spPr>
+      </p:sp>
+      <p:sp>
+        <p:nvSpPr>
+          <p:cNvPr id="10" name="Shape 8"/>
+          <p:cNvSpPr/>
+          <p:nvPr/>
+        </p:nvSpPr>
+        <p:spPr>
+          <a:xfrm>
+            <a:off x="868680" y="4137660"/>
+            <a:ext cx="548640" cy="548640"/>
+          </a:xfrm>
+          <a:prstGeom prst="ellipse">
+            <a:avLst/>
+          </a:prstGeom>
+          <a:solidFill>
+            <a:srgbClr val="FFBA08"/>
+          </a:solidFill>
+          <a:ln/>
+        </p:spPr>
+      </p:sp>
+      <p:sp>
+        <p:nvSpPr>
+          <p:cNvPr id="11" name="Text 9"/>
+          <p:cNvSpPr txBox="1"/>
+          <p:nvPr/>
+        </p:nvSpPr>
+        <p:spPr>
+          <a:xfrm>
+            <a:off x="868680" y="4137660"/>
+            <a:ext cx="548640" cy="548640"/>
+          </a:xfrm>
+          <a:prstGeom prst="rect">
+            <a:avLst/>
+          </a:prstGeom>
+          <a:noFill/>
+          <a:ln/>
+        </p:spPr>
+        <p:txBody>
+          <a:bodyPr wrap="square" lIns="0" tIns="0" rIns="0" bIns="0" rtlCol="0" anchor="ctr"/>
+          <a:lstStyle/>
+          <a:p>
+            <a:pPr marL="0" indent="0" algn="ctr">
+              <a:buNone/>
+            </a:pPr>
+            <a:r>
+              <a:rPr lang="en-US" sz="1600" dirty="0">
+                <a:solidFill>
+                  <a:srgbClr val="000000"/>
+                </a:solidFill>
+              </a:rPr>
+              <a:t>👨‍🍳</a:t>
+            </a:r>
+            <a:endParaRPr lang="en-US" sz="1600" dirty="0"/>
+          </a:p>
+        </p:txBody>
+      </p:sp>
+      <p:sp>
+        <p:nvSpPr>
+          <p:cNvPr id="12" name="Text 10"/>
+          <p:cNvSpPr txBox="1"/>
+          <p:nvPr/>
+        </p:nvSpPr>
+        <p:spPr>
+          <a:xfrm>
+            <a:off x="1691640" y="3977640"/>
+            <a:ext cx="9601200" cy="868680"/>
+          </a:xfrm>
+          <a:prstGeom prst="rect">
+            <a:avLst/>
+          </a:prstGeom>
+          <a:noFill/>
+          <a:ln/>
+        </p:spPr>
+        <p:txBody>
+          <a:bodyPr wrap="square" lIns="0" tIns="0" rIns="0" bIns="0" rtlCol="0" anchor="ctr"/>
+          <a:lstStyle/>
+          <a:p>
+            <a:pPr marL="0" indent="0">
+              <a:buNone/>
+            </a:pPr>
+            <a:r>
+              <a:rPr lang="en-US" sz="1700" dirty="0">
+                <a:solidFill>
+                  <a:srgbClr val="2B1B12"/>
+                </a:solidFill>
+                <a:latin typeface="Calibri" pitchFamily="34" charset="0"/>
+                <a:ea typeface="Calibri" pitchFamily="34" charset="-122"/>
+                <a:cs typeface="Calibri" pitchFamily="34" charset="-120"/>
+              </a:rPr>
               <a:t>I will use AI to invent a brand new recipe when nothing matches.</a:t>
             </a:r>
             <a:endParaRPr lang="en-US" sz="1700" dirty="0"/>
+          </a:p>
+        </p:txBody>
+      </p:sp>
+    </p:spTree>
+  </p:cSld>
+  <p:clrMapOvr>
+    <a:masterClrMapping/>
+  </p:clrMapOvr>
+</p:sld>
+</file>
+
+<file path=ppt/slides/slide6.xml><?xml version="1.0" encoding="utf-8"?>
+<p:sld xmlns:a="http://schemas.openxmlformats.org/drawingml/2006/main" xmlns:r="http://schemas.openxmlformats.org/officeDocument/2006/relationships" xmlns:p="http://schemas.openxmlformats.org/presentationml/2006/main">
+  <p:cSld name="Slide 6">
+    <p:bg>
+      <p:bgPr>
+        <a:solidFill>
+          <a:srgbClr val="FFFFFF"/>
+        </a:solidFill>
+        <a:effectLst/>
+      </p:bgPr>
+    </p:bg>
+    <p:spTree>
+      <p:nvGrpSpPr>
+        <p:cNvPr id="1" name=""/>
+        <p:cNvGrpSpPr/>
+        <p:nvPr/>
+      </p:nvGrpSpPr>
+      <p:grpSpPr>
+        <a:xfrm>
+          <a:off x="0" y="0"/>
+          <a:ext cx="0" cy="0"/>
+          <a:chOff x="0" y="0"/>
+          <a:chExt cx="0" cy="0"/>
+        </a:xfrm>
+      </p:grpSpPr>
+      <p:sp>
+        <p:nvSpPr>
+          <p:cNvPr id="2" name="Shape 0"/>
+          <p:cNvSpPr/>
+          <p:nvPr/>
+        </p:nvSpPr>
+        <p:spPr>
+          <a:xfrm>
+            <a:off x="0" y="0"/>
+            <a:ext cx="12188952" cy="1188720"/>
+          </a:xfrm>
+          <a:prstGeom prst="rect">
+            <a:avLst/>
+          </a:prstGeom>
+          <a:solidFill>
+            <a:srgbClr val="D84315"/>
+          </a:solidFill>
+          <a:ln/>
+        </p:spPr>
+      </p:sp>
+      <p:sp>
+        <p:nvSpPr>
+          <p:cNvPr id="3" name="Shape 1"/>
+          <p:cNvSpPr/>
+          <p:nvPr/>
+        </p:nvSpPr>
+        <p:spPr>
+          <a:xfrm>
+            <a:off x="457200" y="228600"/>
+            <a:ext cx="731520" cy="731520"/>
+          </a:xfrm>
+          <a:prstGeom prst="ellipse">
+            <a:avLst/>
+          </a:prstGeom>
+          <a:solidFill>
+            <a:srgbClr val="FFFFFF"/>
+          </a:solidFill>
+          <a:ln/>
+        </p:spPr>
+      </p:sp>
+      <p:sp>
+        <p:nvSpPr>
+          <p:cNvPr id="4" name="Text 2"/>
+          <p:cNvSpPr txBox="1"/>
+          <p:nvPr/>
+        </p:nvSpPr>
+        <p:spPr>
+          <a:xfrm>
+            <a:off x="457200" y="228600"/>
+            <a:ext cx="731520" cy="731520"/>
+          </a:xfrm>
+          <a:prstGeom prst="rect">
+            <a:avLst/>
+          </a:prstGeom>
+          <a:noFill/>
+          <a:ln/>
+        </p:spPr>
+        <p:txBody>
+          <a:bodyPr wrap="square" lIns="0" tIns="0" rIns="0" bIns="0" rtlCol="0" anchor="ctr"/>
+          <a:lstStyle/>
+          <a:p>
+            <a:pPr marL="0" indent="0" algn="ctr">
+              <a:buNone/>
+            </a:pPr>
+            <a:r>
+              <a:rPr lang="en-US" sz="2100" dirty="0">
+                <a:solidFill>
+                  <a:srgbClr val="000000"/>
+                </a:solidFill>
+              </a:rPr>
+              <a:t>🍳</a:t>
+            </a:r>
+            <a:endParaRPr lang="en-US" sz="2100" dirty="0"/>
+          </a:p>
+        </p:txBody>
+      </p:sp>
+      <p:sp>
+        <p:nvSpPr>
+          <p:cNvPr id="5" name="Text 3"/>
+          <p:cNvSpPr txBox="1"/>
+          <p:nvPr/>
+        </p:nvSpPr>
+        <p:spPr>
+          <a:xfrm>
+            <a:off x="1371600" y="182880"/>
+            <a:ext cx="9601200" cy="822960"/>
+          </a:xfrm>
+          <a:prstGeom prst="rect">
+            <a:avLst/>
+          </a:prstGeom>
+          <a:noFill/>
+          <a:ln/>
+        </p:spPr>
+        <p:txBody>
+          <a:bodyPr wrap="square" lIns="0" tIns="0" rIns="0" bIns="0" rtlCol="0" anchor="ctr"/>
+          <a:lstStyle/>
+          <a:p>
+            <a:pPr marL="0" indent="0">
+              <a:buNone/>
+            </a:pPr>
+            <a:r>
+              <a:rPr lang="en-US" sz="2400" b="1" dirty="0">
+                <a:solidFill>
+                  <a:srgbClr val="FFFFFF"/>
+                </a:solidFill>
+                <a:latin typeface="Cambria" pitchFamily="34" charset="0"/>
+                <a:ea typeface="Cambria" pitchFamily="34" charset="-122"/>
+                <a:cs typeface="Cambria" pitchFamily="34" charset="-120"/>
+              </a:rPr>
+              <a:t>Meal Planner</a:t>
+            </a:r>
+            <a:endParaRPr lang="en-US" sz="2400" dirty="0"/>
+          </a:p>
+        </p:txBody>
+      </p:sp>
+      <p:sp>
+        <p:nvSpPr>
+          <p:cNvPr id="6" name="Shape 4"/>
+          <p:cNvSpPr/>
+          <p:nvPr/>
+        </p:nvSpPr>
+        <p:spPr>
+          <a:xfrm>
+            <a:off x="640080" y="1737360"/>
+            <a:ext cx="5257800" cy="4297680"/>
+          </a:xfrm>
+          <a:prstGeom prst="roundRect">
+            <a:avLst>
+              <a:gd name="adj" fmla="val 2128"/>
+            </a:avLst>
+          </a:prstGeom>
+          <a:solidFill>
+            <a:srgbClr val="FFF3E8"/>
+          </a:solidFill>
+          <a:ln/>
+        </p:spPr>
+      </p:sp>
+      <p:sp>
+        <p:nvSpPr>
+          <p:cNvPr id="7" name="Shape 5"/>
+          <p:cNvSpPr/>
+          <p:nvPr/>
+        </p:nvSpPr>
+        <p:spPr>
+          <a:xfrm>
+            <a:off x="1005840" y="2103120"/>
+            <a:ext cx="640080" cy="640080"/>
+          </a:xfrm>
+          <a:prstGeom prst="ellipse">
+            <a:avLst/>
+          </a:prstGeom>
+          <a:solidFill>
+            <a:srgbClr val="F77F00"/>
+          </a:solidFill>
+          <a:ln/>
+        </p:spPr>
+      </p:sp>
+      <p:sp>
+        <p:nvSpPr>
+          <p:cNvPr id="8" name="Text 6"/>
+          <p:cNvSpPr txBox="1"/>
+          <p:nvPr/>
+        </p:nvSpPr>
+        <p:spPr>
+          <a:xfrm>
+            <a:off x="1005840" y="2103120"/>
+            <a:ext cx="640080" cy="640080"/>
+          </a:xfrm>
+          <a:prstGeom prst="rect">
+            <a:avLst/>
+          </a:prstGeom>
+          <a:noFill/>
+          <a:ln/>
+        </p:spPr>
+        <p:txBody>
+          <a:bodyPr wrap="square" lIns="0" tIns="0" rIns="0" bIns="0" rtlCol="0" anchor="ctr"/>
+          <a:lstStyle/>
+          <a:p>
+            <a:pPr marL="0" indent="0" algn="ctr">
+              <a:buNone/>
+            </a:pPr>
+            <a:r>
+              <a:rPr lang="en-US" sz="1800" dirty="0">
+                <a:solidFill>
+                  <a:srgbClr val="000000"/>
+                </a:solidFill>
+              </a:rPr>
+              <a:t>🎯</a:t>
+            </a:r>
+            <a:endParaRPr lang="en-US" sz="1800" dirty="0"/>
+          </a:p>
+        </p:txBody>
+      </p:sp>
+      <p:sp>
+        <p:nvSpPr>
+          <p:cNvPr id="9" name="Text 7"/>
+          <p:cNvSpPr txBox="1"/>
+          <p:nvPr/>
+        </p:nvSpPr>
+        <p:spPr>
+          <a:xfrm>
+            <a:off x="1828800" y="2148840"/>
+            <a:ext cx="3794760" cy="548640"/>
+          </a:xfrm>
+          <a:prstGeom prst="rect">
+            <a:avLst/>
+          </a:prstGeom>
+          <a:noFill/>
+          <a:ln/>
+        </p:spPr>
+        <p:txBody>
+          <a:bodyPr wrap="square" lIns="0" tIns="0" rIns="0" bIns="0" rtlCol="0" anchor="ctr"/>
+          <a:lstStyle/>
+          <a:p>
+            <a:pPr marL="0" indent="0">
+              <a:buNone/>
+            </a:pPr>
+            <a:r>
+              <a:rPr lang="en-US" sz="2000" b="1" dirty="0">
+                <a:solidFill>
+                  <a:srgbClr val="2B1B12"/>
+                </a:solidFill>
+                <a:latin typeface="Cambria" pitchFamily="34" charset="0"/>
+                <a:ea typeface="Cambria" pitchFamily="34" charset="-122"/>
+                <a:cs typeface="Cambria" pitchFamily="34" charset="-120"/>
+              </a:rPr>
+              <a:t>Target Audience</a:t>
+            </a:r>
+            <a:endParaRPr lang="en-US" sz="2000" dirty="0"/>
+          </a:p>
+        </p:txBody>
+      </p:sp>
+      <p:sp>
+        <p:nvSpPr>
+          <p:cNvPr id="10" name="Text 8"/>
+          <p:cNvSpPr txBox="1"/>
+          <p:nvPr/>
+        </p:nvSpPr>
+        <p:spPr>
+          <a:xfrm>
+            <a:off x="1005840" y="2971800"/>
+            <a:ext cx="4526280" cy="2743200"/>
+          </a:xfrm>
+          <a:prstGeom prst="rect">
+            <a:avLst/>
+          </a:prstGeom>
+          <a:noFill/>
+          <a:ln/>
+        </p:spPr>
+        <p:txBody>
+          <a:bodyPr wrap="square" lIns="0" tIns="0" rIns="0" bIns="0" rtlCol="0" anchor="ctr"/>
+          <a:lstStyle/>
+          <a:p>
+            <a:pPr marL="0" indent="0">
+              <a:lnSpc>
+                <a:spcPct val="130000"/>
+              </a:lnSpc>
+              <a:buNone/>
+            </a:pPr>
+            <a:r>
+              <a:rPr lang="en-US" sz="1500" dirty="0">
+                <a:solidFill>
+                  <a:srgbClr val="2B1B12"/>
+                </a:solidFill>
+                <a:latin typeface="Calibri" pitchFamily="34" charset="0"/>
+                <a:ea typeface="Calibri" pitchFamily="34" charset="-122"/>
+                <a:cs typeface="Calibri" pitchFamily="34" charset="-120"/>
+              </a:rPr>
+              <a:t>Home cooks who don't want to waste food or make an extra grocery run, students on a budget, and people working toward a weight or fitness goal who want meals that actually fit their plan.</a:t>
+            </a:r>
+            <a:endParaRPr lang="en-US" sz="1500" dirty="0"/>
+          </a:p>
+        </p:txBody>
+      </p:sp>
+      <p:sp>
+        <p:nvSpPr>
+          <p:cNvPr id="11" name="Shape 9"/>
+          <p:cNvSpPr/>
+          <p:nvPr/>
+        </p:nvSpPr>
+        <p:spPr>
+          <a:xfrm>
+            <a:off x="6263640" y="1737360"/>
+            <a:ext cx="5257800" cy="4297680"/>
+          </a:xfrm>
+          <a:prstGeom prst="roundRect">
+            <a:avLst>
+              <a:gd name="adj" fmla="val 2128"/>
+            </a:avLst>
+          </a:prstGeom>
+          <a:solidFill>
+            <a:srgbClr val="FFF3E8"/>
+          </a:solidFill>
+          <a:ln/>
+        </p:spPr>
+      </p:sp>
+      <p:sp>
+        <p:nvSpPr>
+          <p:cNvPr id="12" name="Shape 10"/>
+          <p:cNvSpPr/>
+          <p:nvPr/>
+        </p:nvSpPr>
+        <p:spPr>
+          <a:xfrm>
+            <a:off x="6629400" y="2103120"/>
+            <a:ext cx="640080" cy="640080"/>
+          </a:xfrm>
+          <a:prstGeom prst="ellipse">
+            <a:avLst/>
+          </a:prstGeom>
+          <a:solidFill>
+            <a:srgbClr val="FFBA08"/>
+          </a:solidFill>
+          <a:ln/>
+        </p:spPr>
+      </p:sp>
+      <p:sp>
+        <p:nvSpPr>
+          <p:cNvPr id="13" name="Text 11"/>
+          <p:cNvSpPr txBox="1"/>
+          <p:nvPr/>
+        </p:nvSpPr>
+        <p:spPr>
+          <a:xfrm>
+            <a:off x="6629400" y="2103120"/>
+            <a:ext cx="640080" cy="640080"/>
+          </a:xfrm>
+          <a:prstGeom prst="rect">
+            <a:avLst/>
+          </a:prstGeom>
+          <a:noFill/>
+          <a:ln/>
+        </p:spPr>
+        <p:txBody>
+          <a:bodyPr wrap="square" lIns="0" tIns="0" rIns="0" bIns="0" rtlCol="0" anchor="ctr"/>
+          <a:lstStyle/>
+          <a:p>
+            <a:pPr marL="0" indent="0" algn="ctr">
+              <a:buNone/>
+            </a:pPr>
+            <a:r>
+              <a:rPr lang="en-US" sz="1800" dirty="0">
+                <a:solidFill>
+                  <a:srgbClr val="000000"/>
+                </a:solidFill>
+              </a:rPr>
+              <a:t>💡</a:t>
+            </a:r>
+            <a:endParaRPr lang="en-US" sz="1800" dirty="0"/>
+          </a:p>
+        </p:txBody>
+      </p:sp>
+      <p:sp>
+        <p:nvSpPr>
+          <p:cNvPr id="14" name="Text 12"/>
+          <p:cNvSpPr txBox="1"/>
+          <p:nvPr/>
+        </p:nvSpPr>
+        <p:spPr>
+          <a:xfrm>
+            <a:off x="7452360" y="2148840"/>
+            <a:ext cx="3794760" cy="548640"/>
+          </a:xfrm>
+          <a:prstGeom prst="rect">
+            <a:avLst/>
+          </a:prstGeom>
+          <a:noFill/>
+          <a:ln/>
+        </p:spPr>
+        <p:txBody>
+          <a:bodyPr wrap="square" lIns="0" tIns="0" rIns="0" bIns="0" rtlCol="0" anchor="ctr"/>
+          <a:lstStyle/>
+          <a:p>
+            <a:pPr marL="0" indent="0">
+              <a:buNone/>
+            </a:pPr>
+            <a:r>
+              <a:rPr lang="en-US" sz="2000" b="1" dirty="0">
+                <a:solidFill>
+                  <a:srgbClr val="2B1B12"/>
+                </a:solidFill>
+                <a:latin typeface="Cambria" pitchFamily="34" charset="0"/>
+                <a:ea typeface="Cambria" pitchFamily="34" charset="-122"/>
+                <a:cs typeface="Cambria" pitchFamily="34" charset="-120"/>
+              </a:rPr>
+              <a:t>Added Value</a:t>
+            </a:r>
+            <a:endParaRPr lang="en-US" sz="2000" dirty="0"/>
+          </a:p>
+        </p:txBody>
+      </p:sp>
+      <p:sp>
+        <p:nvSpPr>
+          <p:cNvPr id="15" name="Text 13"/>
+          <p:cNvSpPr txBox="1"/>
+          <p:nvPr/>
+        </p:nvSpPr>
+        <p:spPr>
+          <a:xfrm>
+            <a:off x="6629400" y="2971800"/>
+            <a:ext cx="4526280" cy="2743200"/>
+          </a:xfrm>
+          <a:prstGeom prst="rect">
+            <a:avLst/>
+          </a:prstGeom>
+          <a:noFill/>
+          <a:ln/>
+        </p:spPr>
+        <p:txBody>
+          <a:bodyPr wrap="square" lIns="0" tIns="0" rIns="0" bIns="0" rtlCol="0" anchor="ctr"/>
+          <a:lstStyle/>
+          <a:p>
+            <a:pPr marL="0" indent="0">
+              <a:lnSpc>
+                <a:spcPct val="130000"/>
+              </a:lnSpc>
+              <a:buNone/>
+            </a:pPr>
+            <a:r>
+              <a:rPr lang="en-US" sz="1500" dirty="0">
+                <a:solidFill>
+                  <a:srgbClr val="2B1B12"/>
+                </a:solidFill>
+                <a:latin typeface="Calibri" pitchFamily="34" charset="0"/>
+                <a:ea typeface="Calibri" pitchFamily="34" charset="-122"/>
+                <a:cs typeface="Calibri" pitchFamily="34" charset="-120"/>
+              </a:rPr>
+              <a:t>Normal recipe apps leave you stuck when nothing matches your ingredients. This app never leaves you with no answer when there's no match, the AI invents a brand new recipe on the spot, and everything is tied to your personal health goals.</a:t>
+            </a:r>
+            <a:endParaRPr lang="en-US" sz="1500" dirty="0"/>
           </a:p>
         </p:txBody>
       </p:sp>

</xml_diff>

<commit_message>
edited the age range
</commit_message>
<xml_diff>
--- a/three_ideas.pptx
+++ b/three_ideas.pptx
@@ -1853,7 +1853,29 @@
                 <a:ea typeface="Calibri" pitchFamily="34" charset="-122"/>
                 <a:cs typeface="Calibri" pitchFamily="34" charset="-120"/>
               </a:rPr>
-              <a:t>People who watch a lot of shows and movies and lose track of what they've seen casual binge-watchers, students unwinding between classes, and anyone tired of scrolling for 20 minutes before picking something to watch.</a:t>
+              <a:t>People who watch a lot of shows and movies and lose track of what they've seen casual binge-watchers, and anyone tired of scrolling for 20 minutes before picking something to watch, I would range the age </a:t>
+            </a:r>
+            <a:r>
+              <a:rPr lang="en-US" sz="1500" dirty="0" err="1">
+                <a:solidFill>
+                  <a:srgbClr val="2B1B12"/>
+                </a:solidFill>
+                <a:latin typeface="Calibri" pitchFamily="34" charset="0"/>
+                <a:ea typeface="Calibri" pitchFamily="34" charset="-122"/>
+                <a:cs typeface="Calibri" pitchFamily="34" charset="-120"/>
+              </a:rPr>
+              <a:t>berween</a:t>
+            </a:r>
+            <a:r>
+              <a:rPr lang="en-US" sz="1500" dirty="0">
+                <a:solidFill>
+                  <a:srgbClr val="2B1B12"/>
+                </a:solidFill>
+                <a:latin typeface="Calibri" pitchFamily="34" charset="0"/>
+                <a:ea typeface="Calibri" pitchFamily="34" charset="-122"/>
+                <a:cs typeface="Calibri" pitchFamily="34" charset="-120"/>
+              </a:rPr>
+              <a:t> 15 till 30 years old.</a:t>
             </a:r>
             <a:endParaRPr lang="en-US" sz="1500" dirty="0"/>
           </a:p>
@@ -2821,7 +2843,7 @@
                 <a:ea typeface="Calibri" pitchFamily="34" charset="-122"/>
                 <a:cs typeface="Calibri" pitchFamily="34" charset="-120"/>
               </a:rPr>
-              <a:t>Busy people and students who want a real vacation plan without spending hours researching first-time travelers, people planning short trips, and anyone who wants a plan built for them instead of building it themselves.</a:t>
+              <a:t>I would target the age range of 25 till 40 years old .</a:t>
             </a:r>
             <a:endParaRPr lang="en-US" sz="1500" dirty="0"/>
           </a:p>
@@ -3672,7 +3694,7 @@
                 <a:ea typeface="Calibri" pitchFamily="34" charset="-122"/>
                 <a:cs typeface="Calibri" pitchFamily="34" charset="-120"/>
               </a:rPr>
-              <a:t>Home cooks who don't want to waste food or make an extra grocery run, students on a budget, and people working toward a weight or fitness goal who want meals that actually fit their plan.</a:t>
+              <a:t>I would target 19 till 33 years old.</a:t>
             </a:r>
             <a:endParaRPr lang="en-US" sz="1500" dirty="0"/>
           </a:p>

</xml_diff>